<commit_message>
Add interim Eyesel-data assumptions to board briefing and deck
New briefing section 6 and deck slide 12: fairness by mechanism while
Eyesel financials are pending - stated-basis peg with mandatory >15%
equalisation (Amendment A1), verified financials as CP to the share
exchange, escrow holdback fallback, method parity; planning numbers
($8.0M rev / 40% GM / $15-20M parity band); the >=~$18M value check;
and the block-entry decoupling of the FVH ratio from Eyesel data.
</commit_message>
<xml_diff>
--- a/synexo/GenApep_Executive_Presentation.pptx
+++ b/synexo/GenApep_Executive_Presentation.pptx
@@ -21,6 +21,7 @@
     <p:sldId id="269" r:id="rId20"/>
     <p:sldId id="270" r:id="rId21"/>
     <p:sldId id="271" r:id="rId22"/>
+    <p:sldId id="272" r:id="rId23"/>
   </p:sldIdLst>
   <p:sldSz cx="12191695" cy="6858000" type="screen4x3"/>
   <p:notesSz cx="6858000" cy="9144000"/>
@@ -5767,7 +5768,7 @@
                 </a:solidFill>
                 <a:latin typeface="Calibri"/>
               </a:rPr>
-              <a:t>What this means for WBI shareholders</a:t>
+              <a:t>Fair without Eyesel's numbers — interim assumptions</a:t>
             </a:r>
           </a:p>
         </p:txBody>
@@ -5806,7 +5807,7 @@
                 </a:solidFill>
                 <a:latin typeface="Calibri"/>
               </a:rPr>
-              <a:t>Your 49% of GenApep, traced through both routes</a:t>
+              <a:t>Fairness comes from mechanism, not from guessing the missing data</a:t>
             </a:r>
           </a:p>
         </p:txBody>
@@ -5858,444 +5859,8 @@
         </p:nvSpPr>
         <p:spPr>
           <a:xfrm>
-            <a:off x="640080" y="1554480"/>
-            <a:ext cx="2606040" cy="1965960"/>
-          </a:xfrm>
-          <a:prstGeom prst="roundRect">
-            <a:avLst/>
-          </a:prstGeom>
-          <a:solidFill>
-            <a:srgbClr val="2E86C1"/>
-          </a:solidFill>
-          <a:ln>
-            <a:noFill/>
-          </a:ln>
-        </p:spPr>
-        <p:style>
-          <a:lnRef idx="1">
-            <a:schemeClr val="accent1"/>
-          </a:lnRef>
-          <a:fillRef idx="3">
-            <a:schemeClr val="accent1"/>
-          </a:fillRef>
-          <a:effectRef idx="2">
-            <a:schemeClr val="accent1"/>
-          </a:effectRef>
-          <a:fontRef idx="minor">
-            <a:schemeClr val="lt1"/>
-          </a:fontRef>
-        </p:style>
-        <p:txBody>
-          <a:bodyPr rtlCol="0" anchor="ctr" wrap="square" lIns="76200" rIns="76200" tIns="38100" bIns="38100"/>
-          <a:lstStyle/>
-          <a:p>
-            <a:pPr algn="ctr"/>
-            <a:r>
-              <a:rPr sz="1400" b="1">
-                <a:solidFill>
-                  <a:srgbClr val="CFDDEA"/>
-                </a:solidFill>
-                <a:latin typeface="Calibri"/>
-              </a:rPr>
-              <a:t>Today</a:t>
-            </a:r>
-          </a:p>
-          <a:p>
-            <a:pPr algn="ctr"/>
-            <a:r>
-              <a:rPr sz="3000" b="1">
-                <a:solidFill>
-                  <a:srgbClr val="FFFFFF"/>
-                </a:solidFill>
-                <a:latin typeface="Calibri"/>
-              </a:rPr>
-              <a:t>49%</a:t>
-            </a:r>
-          </a:p>
-          <a:p>
-            <a:pPr algn="ctr"/>
-            <a:r>
-              <a:rPr sz="1150" b="0">
-                <a:solidFill>
-                  <a:srgbClr val="FFFFFF"/>
-                </a:solidFill>
-                <a:latin typeface="Calibri"/>
-              </a:rPr>
-              <a:t>of GenApep · ≈ $17.2M at $35M mid</a:t>
-            </a:r>
-          </a:p>
-        </p:txBody>
-      </p:sp>
-      <p:sp>
-        <p:nvSpPr>
-          <p:cNvPr id="8" name="Right Arrow 7"/>
-          <p:cNvSpPr/>
-          <p:nvPr/>
-        </p:nvSpPr>
-        <p:spPr>
-          <a:xfrm>
-            <a:off x="3264408" y="2331720"/>
-            <a:ext cx="182880" cy="411480"/>
-          </a:xfrm>
-          <a:prstGeom prst="rightArrow">
-            <a:avLst/>
-          </a:prstGeom>
-          <a:solidFill>
-            <a:srgbClr val="5A5A5A"/>
-          </a:solidFill>
-          <a:ln>
-            <a:noFill/>
-          </a:ln>
-          <a:effectLst/>
-        </p:spPr>
-        <p:style>
-          <a:lnRef idx="1">
-            <a:schemeClr val="accent1"/>
-          </a:lnRef>
-          <a:fillRef idx="3">
-            <a:schemeClr val="accent1"/>
-          </a:fillRef>
-          <a:effectRef idx="2">
-            <a:schemeClr val="accent1"/>
-          </a:effectRef>
-          <a:fontRef idx="minor">
-            <a:schemeClr val="lt1"/>
-          </a:fontRef>
-        </p:style>
-        <p:txBody>
-          <a:bodyPr rtlCol="0" anchor="ctr"/>
-          <a:lstStyle/>
-          <a:p>
-            <a:pPr algn="ctr"/>
-          </a:p>
-        </p:txBody>
-      </p:sp>
-      <p:sp>
-        <p:nvSpPr>
-          <p:cNvPr id="9" name="Rounded Rectangle 8"/>
-          <p:cNvSpPr/>
-          <p:nvPr/>
-        </p:nvSpPr>
-        <p:spPr>
-          <a:xfrm>
-            <a:off x="3456432" y="1554480"/>
-            <a:ext cx="2606040" cy="1965960"/>
-          </a:xfrm>
-          <a:prstGeom prst="roundRect">
-            <a:avLst/>
-          </a:prstGeom>
-          <a:solidFill>
-            <a:srgbClr val="1AA19C"/>
-          </a:solidFill>
-          <a:ln>
-            <a:noFill/>
-          </a:ln>
-        </p:spPr>
-        <p:style>
-          <a:lnRef idx="1">
-            <a:schemeClr val="accent1"/>
-          </a:lnRef>
-          <a:fillRef idx="3">
-            <a:schemeClr val="accent1"/>
-          </a:fillRef>
-          <a:effectRef idx="2">
-            <a:schemeClr val="accent1"/>
-          </a:effectRef>
-          <a:fontRef idx="minor">
-            <a:schemeClr val="lt1"/>
-          </a:fontRef>
-        </p:style>
-        <p:txBody>
-          <a:bodyPr rtlCol="0" anchor="ctr" wrap="square" lIns="76200" rIns="76200" tIns="38100" bIns="38100"/>
-          <a:lstStyle/>
-          <a:p>
-            <a:pPr algn="ctr"/>
-            <a:r>
-              <a:rPr sz="1400" b="1">
-                <a:solidFill>
-                  <a:srgbClr val="CFDDEA"/>
-                </a:solidFill>
-                <a:latin typeface="Calibri"/>
-              </a:rPr>
-              <a:t>After pool (7.5%)</a:t>
-            </a:r>
-          </a:p>
-          <a:p>
-            <a:pPr algn="ctr"/>
-            <a:r>
-              <a:rPr sz="3000" b="1">
-                <a:solidFill>
-                  <a:srgbClr val="FFFFFF"/>
-                </a:solidFill>
-                <a:latin typeface="Calibri"/>
-              </a:rPr>
-              <a:t>45.3%</a:t>
-            </a:r>
-          </a:p>
-          <a:p>
-            <a:pPr algn="ctr"/>
-            <a:r>
-              <a:rPr sz="1150" b="0">
-                <a:solidFill>
-                  <a:srgbClr val="FFFFFF"/>
-                </a:solidFill>
-                <a:latin typeface="Calibri"/>
-              </a:rPr>
-              <a:t>≈ $15.9M — before technology credit</a:t>
-            </a:r>
-          </a:p>
-        </p:txBody>
-      </p:sp>
-      <p:sp>
-        <p:nvSpPr>
-          <p:cNvPr id="10" name="Right Arrow 9"/>
-          <p:cNvSpPr/>
-          <p:nvPr/>
-        </p:nvSpPr>
-        <p:spPr>
-          <a:xfrm>
-            <a:off x="6080760" y="2331720"/>
-            <a:ext cx="182880" cy="411480"/>
-          </a:xfrm>
-          <a:prstGeom prst="rightArrow">
-            <a:avLst/>
-          </a:prstGeom>
-          <a:solidFill>
-            <a:srgbClr val="5A5A5A"/>
-          </a:solidFill>
-          <a:ln>
-            <a:noFill/>
-          </a:ln>
-          <a:effectLst/>
-        </p:spPr>
-        <p:style>
-          <a:lnRef idx="1">
-            <a:schemeClr val="accent1"/>
-          </a:lnRef>
-          <a:fillRef idx="3">
-            <a:schemeClr val="accent1"/>
-          </a:fillRef>
-          <a:effectRef idx="2">
-            <a:schemeClr val="accent1"/>
-          </a:effectRef>
-          <a:fontRef idx="minor">
-            <a:schemeClr val="lt1"/>
-          </a:fontRef>
-        </p:style>
-        <p:txBody>
-          <a:bodyPr rtlCol="0" anchor="ctr"/>
-          <a:lstStyle/>
-          <a:p>
-            <a:pPr algn="ctr"/>
-          </a:p>
-        </p:txBody>
-      </p:sp>
-      <p:sp>
-        <p:nvSpPr>
-          <p:cNvPr id="11" name="Rounded Rectangle 10"/>
-          <p:cNvSpPr/>
-          <p:nvPr/>
-        </p:nvSpPr>
-        <p:spPr>
-          <a:xfrm>
-            <a:off x="6272784" y="1554480"/>
-            <a:ext cx="2606040" cy="1965960"/>
-          </a:xfrm>
-          <a:prstGeom prst="roundRect">
-            <a:avLst/>
-          </a:prstGeom>
-          <a:solidFill>
-            <a:srgbClr val="E09E2B"/>
-          </a:solidFill>
-          <a:ln>
-            <a:noFill/>
-          </a:ln>
-        </p:spPr>
-        <p:style>
-          <a:lnRef idx="1">
-            <a:schemeClr val="accent1"/>
-          </a:lnRef>
-          <a:fillRef idx="3">
-            <a:schemeClr val="accent1"/>
-          </a:fillRef>
-          <a:effectRef idx="2">
-            <a:schemeClr val="accent1"/>
-          </a:effectRef>
-          <a:fontRef idx="minor">
-            <a:schemeClr val="lt1"/>
-          </a:fontRef>
-        </p:style>
-        <p:txBody>
-          <a:bodyPr rtlCol="0" anchor="ctr" wrap="square" lIns="76200" rIns="76200" tIns="38100" bIns="38100"/>
-          <a:lstStyle/>
-          <a:p>
-            <a:pPr algn="ctr"/>
-            <a:r>
-              <a:rPr sz="1400" b="1">
-                <a:solidFill>
-                  <a:srgbClr val="FFFFFF"/>
-                </a:solidFill>
-                <a:latin typeface="Calibri"/>
-              </a:rPr>
-              <a:t>Route B (FVH $10M)</a:t>
-            </a:r>
-          </a:p>
-          <a:p>
-            <a:pPr algn="ctr"/>
-            <a:r>
-              <a:rPr sz="3000" b="1">
-                <a:solidFill>
-                  <a:srgbClr val="FFFFFF"/>
-                </a:solidFill>
-                <a:latin typeface="Calibri"/>
-              </a:rPr>
-              <a:t>35.3%</a:t>
-            </a:r>
-          </a:p>
-          <a:p>
-            <a:pPr algn="ctr"/>
-            <a:r>
-              <a:rPr sz="1150" b="0">
-                <a:solidFill>
-                  <a:srgbClr val="FFFFFF"/>
-                </a:solidFill>
-                <a:latin typeface="Calibri"/>
-              </a:rPr>
-              <a:t>of the LISTED company · $28–35M if market values group at $80–100M</a:t>
-            </a:r>
-          </a:p>
-        </p:txBody>
-      </p:sp>
-      <p:sp>
-        <p:nvSpPr>
-          <p:cNvPr id="12" name="Right Arrow 11"/>
-          <p:cNvSpPr/>
-          <p:nvPr/>
-        </p:nvSpPr>
-        <p:spPr>
-          <a:xfrm>
-            <a:off x="8897112" y="2331720"/>
-            <a:ext cx="182880" cy="411480"/>
-          </a:xfrm>
-          <a:prstGeom prst="rightArrow">
-            <a:avLst/>
-          </a:prstGeom>
-          <a:solidFill>
-            <a:srgbClr val="5A5A5A"/>
-          </a:solidFill>
-          <a:ln>
-            <a:noFill/>
-          </a:ln>
-          <a:effectLst/>
-        </p:spPr>
-        <p:style>
-          <a:lnRef idx="1">
-            <a:schemeClr val="accent1"/>
-          </a:lnRef>
-          <a:fillRef idx="3">
-            <a:schemeClr val="accent1"/>
-          </a:fillRef>
-          <a:effectRef idx="2">
-            <a:schemeClr val="accent1"/>
-          </a:effectRef>
-          <a:fontRef idx="minor">
-            <a:schemeClr val="lt1"/>
-          </a:fontRef>
-        </p:style>
-        <p:txBody>
-          <a:bodyPr rtlCol="0" anchor="ctr"/>
-          <a:lstStyle/>
-          <a:p>
-            <a:pPr algn="ctr"/>
-          </a:p>
-        </p:txBody>
-      </p:sp>
-      <p:sp>
-        <p:nvSpPr>
-          <p:cNvPr id="13" name="Rounded Rectangle 12"/>
-          <p:cNvSpPr/>
-          <p:nvPr/>
-        </p:nvSpPr>
-        <p:spPr>
-          <a:xfrm>
-            <a:off x="9089136" y="1554480"/>
-            <a:ext cx="2606040" cy="1965960"/>
-          </a:xfrm>
-          <a:prstGeom prst="roundRect">
-            <a:avLst/>
-          </a:prstGeom>
-          <a:solidFill>
-            <a:srgbClr val="1B3355"/>
-          </a:solidFill>
-          <a:ln>
-            <a:noFill/>
-          </a:ln>
-        </p:spPr>
-        <p:style>
-          <a:lnRef idx="1">
-            <a:schemeClr val="accent1"/>
-          </a:lnRef>
-          <a:fillRef idx="3">
-            <a:schemeClr val="accent1"/>
-          </a:fillRef>
-          <a:effectRef idx="2">
-            <a:schemeClr val="accent1"/>
-          </a:effectRef>
-          <a:fontRef idx="minor">
-            <a:schemeClr val="lt1"/>
-          </a:fontRef>
-        </p:style>
-        <p:txBody>
-          <a:bodyPr rtlCol="0" anchor="ctr" wrap="square" lIns="76200" rIns="76200" tIns="38100" bIns="38100"/>
-          <a:lstStyle/>
-          <a:p>
-            <a:pPr algn="ctr"/>
-            <a:r>
-              <a:rPr sz="1400" b="1">
-                <a:solidFill>
-                  <a:srgbClr val="CFDDEA"/>
-                </a:solidFill>
-                <a:latin typeface="Calibri"/>
-              </a:rPr>
-              <a:t>Route A post-IPO</a:t>
-            </a:r>
-          </a:p>
-          <a:p>
-            <a:pPr algn="ctr"/>
-            <a:r>
-              <a:rPr sz="3000" b="1">
-                <a:solidFill>
-                  <a:srgbClr val="FFFFFF"/>
-                </a:solidFill>
-                <a:latin typeface="Calibri"/>
-              </a:rPr>
-              <a:t>36.3%</a:t>
-            </a:r>
-          </a:p>
-          <a:p>
-            <a:pPr algn="ctr"/>
-            <a:r>
-              <a:rPr sz="1150" b="0">
-                <a:solidFill>
-                  <a:srgbClr val="FFFFFF"/>
-                </a:solidFill>
-                <a:latin typeface="Calibri"/>
-              </a:rPr>
-              <a:t>≈ $36.3M at $80M pre + $20M raise (workbook)</a:t>
-            </a:r>
-          </a:p>
-        </p:txBody>
-      </p:sp>
-      <p:sp>
-        <p:nvSpPr>
-          <p:cNvPr id="14" name="Rounded Rectangle 13"/>
-          <p:cNvSpPr/>
-          <p:nvPr/>
-        </p:nvSpPr>
-        <p:spPr>
-          <a:xfrm>
-            <a:off x="640080" y="3794760"/>
-            <a:ext cx="5394960" cy="2331720"/>
+            <a:off x="640080" y="1417320"/>
+            <a:ext cx="5760720" cy="4160520"/>
           </a:xfrm>
           <a:prstGeom prst="roundRect">
             <a:avLst/>
@@ -6329,13 +5894,13 @@
           <a:p>
             <a:pPr algn="l"/>
             <a:r>
-              <a:rPr sz="1700" b="1">
+              <a:rPr sz="1600" b="1">
                 <a:solidFill>
                   <a:srgbClr val="1B3355"/>
                 </a:solidFill>
                 <a:latin typeface="Calibri"/>
               </a:rPr>
-              <a:t>Where WBI's value comes from</a:t>
+              <a:t>Four mechanisms — commit now, correct automatically</a:t>
             </a:r>
           </a:p>
           <a:p>
@@ -6345,29 +5910,436 @@
               </a:spcBef>
             </a:pPr>
             <a:r>
-              <a:rPr sz="1350">
+              <a:rPr sz="1250">
                 <a:solidFill>
                   <a:srgbClr val="5A5A5A"/>
                 </a:solidFill>
                 <a:latin typeface="Calibri"/>
               </a:rPr>
-              <a:t>• MM Studio — WBI's growth engine: $2.9M → $36.3M by 2030, the plan's biggest swing factor.
-• WBI core exports: $4.69M in 2026, +20%/yr, NTS-certified FY2025 base.
-• Technology upside (AI.pep, DPW licence) accrues inside GenApep — you participate via the block.</a:t>
-            </a:r>
-          </a:p>
-        </p:txBody>
-      </p:sp>
-      <p:sp>
-        <p:nvSpPr>
-          <p:cNvPr id="15" name="Rounded Rectangle 14"/>
+              <a:t>1 · PEG + MANDATORY TRUE-UP (Amendment A1, already drafted): sign on a stated basis — Eyesel revenue $8.0M, value $15–20M. If verified figures differ &gt;15%, equalisation is mandatory; an independent valuer decides if boards cannot. Symmetric — protects Eyesel too.
+2 · VERIFIED FINANCIALS = condition precedent to the SHARE EXCHANGE, not to signing — the exchange is Q1–Q2 2027 and the PCAOB audit verifies the numbers anyway.
+3 · ESCROW HOLDBACK (fallback): 5–8 points of the Eyesel allocation held until verification.
+4 · PARITY OF METHOD: the same valuer, method and multiples for both companies — agree the method today, the numbers follow from the data.</a:t>
+            </a:r>
+          </a:p>
+        </p:txBody>
+      </p:sp>
+      <p:sp>
+        <p:nvSpPr>
+          <p:cNvPr id="8" name="TextBox 7"/>
+          <p:cNvSpPr txBox="1"/>
+          <p:nvPr/>
+        </p:nvSpPr>
+        <p:spPr>
+          <a:xfrm>
+            <a:off x="6629400" y="1417320"/>
+            <a:ext cx="4937760" cy="365760"/>
+          </a:xfrm>
+          <a:prstGeom prst="rect">
+            <a:avLst/>
+          </a:prstGeom>
+          <a:noFill/>
+        </p:spPr>
+        <p:txBody>
+          <a:bodyPr wrap="square" anchor="t">
+            <a:spAutoFit/>
+          </a:bodyPr>
+          <a:lstStyle/>
+          <a:p>
+            <a:pPr algn="l">
+              <a:spcAft>
+                <a:spcPts val="400"/>
+              </a:spcAft>
+            </a:pPr>
+            <a:r>
+              <a:rPr sz="1500" b="1">
+                <a:solidFill>
+                  <a:srgbClr val="1B3355"/>
+                </a:solidFill>
+                <a:latin typeface="Calibri"/>
+              </a:rPr>
+              <a:t>Planning numbers meanwhile</a:t>
+            </a:r>
+          </a:p>
+        </p:txBody>
+      </p:sp>
+      <p:graphicFrame>
+        <p:nvGraphicFramePr>
+          <p:cNvPr id="9" name="Table 8"/>
+          <p:cNvGraphicFramePr>
+            <a:graphicFrameLocks noGrp="1"/>
+          </p:cNvGraphicFramePr>
+          <p:nvPr/>
+        </p:nvGraphicFramePr>
+        <p:xfrm>
+          <a:off x="6629400" y="1874519"/>
+          <a:ext cx="4937760" cy="1828800"/>
+        </p:xfrm>
+        <a:graphic>
+          <a:graphicData uri="http://schemas.openxmlformats.org/drawingml/2006/table">
+            <a:tbl>
+              <a:tblPr firstRow="1" bandRow="1">
+                <a:tableStyleId>{5C22544A-7EE6-4342-B048-85BDC9FD1C3A}</a:tableStyleId>
+              </a:tblPr>
+              <a:tblGrid>
+                <a:gridCol w="1234440"/>
+                <a:gridCol w="914400"/>
+                <a:gridCol w="2788920"/>
+              </a:tblGrid>
+              <a:tr h="365760">
+                <a:tc>
+                  <a:txBody>
+                    <a:bodyPr/>
+                    <a:lstStyle/>
+                    <a:p>
+                      <a:pPr algn="l"/>
+                      <a:r>
+                        <a:rPr sz="1200" b="1">
+                          <a:solidFill>
+                            <a:srgbClr val="FFFFFF"/>
+                          </a:solidFill>
+                        </a:rPr>
+                        <a:t>Item</a:t>
+                      </a:r>
+                    </a:p>
+                  </a:txBody>
+                  <a:tcPr>
+                    <a:solidFill>
+                      <a:srgbClr val="1B3355"/>
+                    </a:solidFill>
+                  </a:tcPr>
+                </a:tc>
+                <a:tc>
+                  <a:txBody>
+                    <a:bodyPr/>
+                    <a:lstStyle/>
+                    <a:p>
+                      <a:pPr algn="ctr"/>
+                      <a:r>
+                        <a:rPr sz="1200" b="1">
+                          <a:solidFill>
+                            <a:srgbClr val="FFFFFF"/>
+                          </a:solidFill>
+                        </a:rPr>
+                        <a:t>Assume</a:t>
+                      </a:r>
+                    </a:p>
+                  </a:txBody>
+                  <a:tcPr>
+                    <a:solidFill>
+                      <a:srgbClr val="1B3355"/>
+                    </a:solidFill>
+                  </a:tcPr>
+                </a:tc>
+                <a:tc>
+                  <a:txBody>
+                    <a:bodyPr/>
+                    <a:lstStyle/>
+                    <a:p>
+                      <a:pPr algn="ctr"/>
+                      <a:r>
+                        <a:rPr sz="1200" b="1">
+                          <a:solidFill>
+                            <a:srgbClr val="FFFFFF"/>
+                          </a:solidFill>
+                        </a:rPr>
+                        <a:t>Why</a:t>
+                      </a:r>
+                    </a:p>
+                  </a:txBody>
+                  <a:tcPr>
+                    <a:solidFill>
+                      <a:srgbClr val="1B3355"/>
+                    </a:solidFill>
+                  </a:tcPr>
+                </a:tc>
+              </a:tr>
+              <a:tr h="365760">
+                <a:tc>
+                  <a:txBody>
+                    <a:bodyPr/>
+                    <a:lstStyle/>
+                    <a:p>
+                      <a:pPr algn="l"/>
+                      <a:r>
+                        <a:rPr sz="1150" b="1">
+                          <a:solidFill>
+                            <a:srgbClr val="1B3355"/>
+                          </a:solidFill>
+                        </a:rPr>
+                        <a:t>Revenue</a:t>
+                      </a:r>
+                    </a:p>
+                  </a:txBody>
+                  <a:tcPr>
+                    <a:solidFill>
+                      <a:srgbClr val="ECF2F7"/>
+                    </a:solidFill>
+                  </a:tcPr>
+                </a:tc>
+                <a:tc>
+                  <a:txBody>
+                    <a:bodyPr/>
+                    <a:lstStyle/>
+                    <a:p>
+                      <a:pPr algn="ctr"/>
+                      <a:r>
+                        <a:rPr sz="1150" b="0">
+                          <a:solidFill>
+                            <a:srgbClr val="1B3355"/>
+                          </a:solidFill>
+                        </a:rPr>
+                        <a:t>$8.0M</a:t>
+                      </a:r>
+                    </a:p>
+                  </a:txBody>
+                  <a:tcPr>
+                    <a:solidFill>
+                      <a:srgbClr val="ECF2F7"/>
+                    </a:solidFill>
+                  </a:tcPr>
+                </a:tc>
+                <a:tc>
+                  <a:txBody>
+                    <a:bodyPr/>
+                    <a:lstStyle/>
+                    <a:p>
+                      <a:pPr algn="ctr"/>
+                      <a:r>
+                        <a:rPr sz="1150" b="0">
+                          <a:solidFill>
+                            <a:srgbClr val="1B3355"/>
+                          </a:solidFill>
+                        </a:rPr>
+                        <a:t>documented basis (lower figure)</a:t>
+                      </a:r>
+                    </a:p>
+                  </a:txBody>
+                  <a:tcPr>
+                    <a:solidFill>
+                      <a:srgbClr val="ECF2F7"/>
+                    </a:solidFill>
+                  </a:tcPr>
+                </a:tc>
+              </a:tr>
+              <a:tr h="365760">
+                <a:tc>
+                  <a:txBody>
+                    <a:bodyPr/>
+                    <a:lstStyle/>
+                    <a:p>
+                      <a:pPr algn="l"/>
+                      <a:r>
+                        <a:rPr sz="1150" b="1">
+                          <a:solidFill>
+                            <a:srgbClr val="1B3355"/>
+                          </a:solidFill>
+                        </a:rPr>
+                        <a:t>Gross margin</a:t>
+                      </a:r>
+                    </a:p>
+                  </a:txBody>
+                  <a:tcPr>
+                    <a:solidFill>
+                      <a:srgbClr val="FFFFFF"/>
+                    </a:solidFill>
+                  </a:tcPr>
+                </a:tc>
+                <a:tc>
+                  <a:txBody>
+                    <a:bodyPr/>
+                    <a:lstStyle/>
+                    <a:p>
+                      <a:pPr algn="ctr"/>
+                      <a:r>
+                        <a:rPr sz="1150" b="0">
+                          <a:solidFill>
+                            <a:srgbClr val="1B3355"/>
+                          </a:solidFill>
+                        </a:rPr>
+                        <a:t>40%</a:t>
+                      </a:r>
+                    </a:p>
+                  </a:txBody>
+                  <a:tcPr>
+                    <a:solidFill>
+                      <a:srgbClr val="FFFFFF"/>
+                    </a:solidFill>
+                  </a:tcPr>
+                </a:tc>
+                <a:tc>
+                  <a:txBody>
+                    <a:bodyPr/>
+                    <a:lstStyle/>
+                    <a:p>
+                      <a:pPr algn="ctr"/>
+                      <a:r>
+                        <a:rPr sz="1150" b="0">
+                          <a:solidFill>
+                            <a:srgbClr val="1B3355"/>
+                          </a:solidFill>
+                        </a:rPr>
+                        <a:t>mirrors WBI's certified actual</a:t>
+                      </a:r>
+                    </a:p>
+                  </a:txBody>
+                  <a:tcPr>
+                    <a:solidFill>
+                      <a:srgbClr val="FFFFFF"/>
+                    </a:solidFill>
+                  </a:tcPr>
+                </a:tc>
+              </a:tr>
+              <a:tr h="365760">
+                <a:tc>
+                  <a:txBody>
+                    <a:bodyPr/>
+                    <a:lstStyle/>
+                    <a:p>
+                      <a:pPr algn="l"/>
+                      <a:r>
+                        <a:rPr sz="1150" b="1">
+                          <a:solidFill>
+                            <a:srgbClr val="1B3355"/>
+                          </a:solidFill>
+                        </a:rPr>
+                        <a:t>EBITDA</a:t>
+                      </a:r>
+                    </a:p>
+                  </a:txBody>
+                  <a:tcPr>
+                    <a:solidFill>
+                      <a:srgbClr val="ECF2F7"/>
+                    </a:solidFill>
+                  </a:tcPr>
+                </a:tc>
+                <a:tc>
+                  <a:txBody>
+                    <a:bodyPr/>
+                    <a:lstStyle/>
+                    <a:p>
+                      <a:pPr algn="ctr"/>
+                      <a:r>
+                        <a:rPr sz="1150" b="0">
+                          <a:solidFill>
+                            <a:srgbClr val="1B3355"/>
+                          </a:solidFill>
+                        </a:rPr>
+                        <a:t>~12%</a:t>
+                      </a:r>
+                    </a:p>
+                  </a:txBody>
+                  <a:tcPr>
+                    <a:solidFill>
+                      <a:srgbClr val="ECF2F7"/>
+                    </a:solidFill>
+                  </a:tcPr>
+                </a:tc>
+                <a:tc>
+                  <a:txBody>
+                    <a:bodyPr/>
+                    <a:lstStyle/>
+                    <a:p>
+                      <a:pPr algn="ctr"/>
+                      <a:r>
+                        <a:rPr sz="1150" b="0">
+                          <a:solidFill>
+                            <a:srgbClr val="1B3355"/>
+                          </a:solidFill>
+                        </a:rPr>
+                        <a:t>GMP-manufacturer profile</a:t>
+                      </a:r>
+                    </a:p>
+                  </a:txBody>
+                  <a:tcPr>
+                    <a:solidFill>
+                      <a:srgbClr val="ECF2F7"/>
+                    </a:solidFill>
+                  </a:tcPr>
+                </a:tc>
+              </a:tr>
+              <a:tr h="365760">
+                <a:tc>
+                  <a:txBody>
+                    <a:bodyPr/>
+                    <a:lstStyle/>
+                    <a:p>
+                      <a:pPr algn="l"/>
+                      <a:r>
+                        <a:rPr sz="1150" b="1">
+                          <a:solidFill>
+                            <a:srgbClr val="1B3355"/>
+                          </a:solidFill>
+                        </a:rPr>
+                        <a:t>Value band</a:t>
+                      </a:r>
+                    </a:p>
+                  </a:txBody>
+                  <a:tcPr>
+                    <a:solidFill>
+                      <a:srgbClr val="FFFFFF"/>
+                    </a:solidFill>
+                  </a:tcPr>
+                </a:tc>
+                <a:tc>
+                  <a:txBody>
+                    <a:bodyPr/>
+                    <a:lstStyle/>
+                    <a:p>
+                      <a:pPr algn="ctr"/>
+                      <a:r>
+                        <a:rPr sz="1150" b="0">
+                          <a:solidFill>
+                            <a:srgbClr val="1B3355"/>
+                          </a:solidFill>
+                        </a:rPr>
+                        <a:t>$15–20M</a:t>
+                      </a:r>
+                    </a:p>
+                  </a:txBody>
+                  <a:tcPr>
+                    <a:solidFill>
+                      <a:srgbClr val="FFFFFF"/>
+                    </a:solidFill>
+                  </a:tcPr>
+                </a:tc>
+                <a:tc>
+                  <a:txBody>
+                    <a:bodyPr/>
+                    <a:lstStyle/>
+                    <a:p>
+                      <a:pPr algn="ctr"/>
+                      <a:r>
+                        <a:rPr sz="1150" b="0">
+                          <a:solidFill>
+                            <a:srgbClr val="1B3355"/>
+                          </a:solidFill>
+                        </a:rPr>
+                        <a:t>same band as WBI — parity</a:t>
+                      </a:r>
+                    </a:p>
+                  </a:txBody>
+                  <a:tcPr>
+                    <a:solidFill>
+                      <a:srgbClr val="FFFFFF"/>
+                    </a:solidFill>
+                  </a:tcPr>
+                </a:tc>
+              </a:tr>
+            </a:tbl>
+          </a:graphicData>
+        </a:graphic>
+      </p:graphicFrame>
+      <p:sp>
+        <p:nvSpPr>
+          <p:cNvPr id="10" name="Rounded Rectangle 9"/>
           <p:cNvSpPr/>
           <p:nvPr/>
         </p:nvSpPr>
         <p:spPr>
           <a:xfrm>
-            <a:off x="6263640" y="3794760"/>
-            <a:ext cx="5303520" cy="2331720"/>
+            <a:off x="6629400" y="3977639"/>
+            <a:ext cx="4937760" cy="1600200"/>
           </a:xfrm>
           <a:prstGeom prst="roundRect">
             <a:avLst/>
@@ -6377,7 +6349,7 @@
           </a:solidFill>
           <a:ln w="19050">
             <a:solidFill>
-              <a:srgbClr val="C0392B"/>
+              <a:srgbClr val="E09E2B"/>
             </a:solidFill>
           </a:ln>
         </p:spPr>
@@ -6401,13 +6373,13 @@
           <a:p>
             <a:pPr algn="l"/>
             <a:r>
-              <a:rPr sz="1700" b="1">
+              <a:rPr sz="1450" b="1">
                 <a:solidFill>
                   <a:srgbClr val="1B3355"/>
                 </a:solidFill>
                 <a:latin typeface="Calibri"/>
               </a:rPr>
-              <a:t>The protections that matter to you</a:t>
+              <a:t>The check for both boards</a:t>
             </a:r>
           </a:p>
           <a:p>
@@ -6417,15 +6389,66 @@
               </a:spcBef>
             </a:pPr>
             <a:r>
-              <a:rPr sz="1350">
+              <a:rPr sz="1250">
                 <a:solidFill>
                   <a:srgbClr val="5A5A5A"/>
                 </a:solidFill>
                 <a:latin typeface="Calibri"/>
               </a:rPr>
-              <a:t>• A2: consideration only to shareholder bodies, pro rata — the draft's 40% to one individual (zero to other WBI shareholders) becomes impossible.
-• B4/B5: any Stage-2 deal carries every shareholder through as one block at one ratio.
-• A1: if Eyesel's real revenue departs &gt;15% from $8.0M, equalisation is mandatory.</a:t>
+              <a:t>Value-proportional, Eyesel needs ≥ ~$18M verified value to hold 51%. At $8M revenue that means documenting GMP-facility / licence asset value — or equalisation applies. At ~$15M revenue, 51:49 is comfortable.</a:t>
+            </a:r>
+          </a:p>
+        </p:txBody>
+      </p:sp>
+      <p:sp>
+        <p:nvSpPr>
+          <p:cNvPr id="11" name="Rounded Rectangle 10"/>
+          <p:cNvSpPr/>
+          <p:nvPr/>
+        </p:nvSpPr>
+        <p:spPr>
+          <a:xfrm>
+            <a:off x="640080" y="5760720"/>
+            <a:ext cx="10927080" cy="685800"/>
+          </a:xfrm>
+          <a:prstGeom prst="roundRect">
+            <a:avLst/>
+          </a:prstGeom>
+          <a:solidFill>
+            <a:srgbClr val="ECF2F7"/>
+          </a:solidFill>
+          <a:ln>
+            <a:noFill/>
+          </a:ln>
+          <a:effectLst/>
+        </p:spPr>
+        <p:style>
+          <a:lnRef idx="1">
+            <a:schemeClr val="accent1"/>
+          </a:lnRef>
+          <a:fillRef idx="3">
+            <a:schemeClr val="accent1"/>
+          </a:fillRef>
+          <a:effectRef idx="2">
+            <a:schemeClr val="accent1"/>
+          </a:effectRef>
+          <a:fontRef idx="minor">
+            <a:schemeClr val="lt1"/>
+          </a:fontRef>
+        </p:style>
+        <p:txBody>
+          <a:bodyPr rtlCol="0" anchor="ctr" wrap="square" lIns="76200" rIns="76200" tIns="38100" bIns="38100"/>
+          <a:lstStyle/>
+          <a:p>
+            <a:pPr algn="ctr"/>
+            <a:r>
+              <a:rPr sz="1500" b="1">
+                <a:solidFill>
+                  <a:srgbClr val="1B3355"/>
+                </a:solidFill>
+                <a:latin typeface="Calibri"/>
+              </a:rPr>
+              <a:t>The FVH ratio never waits on Eyesel's data — only the internal split does, and it self-corrects inside the block.</a:t>
             </a:r>
           </a:p>
         </p:txBody>
@@ -6570,7 +6593,7 @@
                 </a:solidFill>
                 <a:latin typeface="Calibri"/>
               </a:rPr>
-              <a:t>The price test on First Vital</a:t>
+              <a:t>What this means for WBI shareholders</a:t>
             </a:r>
           </a:p>
         </p:txBody>
@@ -6609,7 +6632,7 @@
                 </a:solidFill>
                 <a:latin typeface="Calibri"/>
               </a:rPr>
-              <a:t>What the draft's percentages imply — and how to check them</a:t>
+              <a:t>Your 49% of GenApep, traced through both routes</a:t>
             </a:r>
           </a:p>
         </p:txBody>
@@ -6649,6 +6672,809 @@
                 <a:latin typeface="Calibri"/>
               </a:rPr>
               <a:t>13</a:t>
+            </a:r>
+          </a:p>
+        </p:txBody>
+      </p:sp>
+      <p:sp>
+        <p:nvSpPr>
+          <p:cNvPr id="7" name="Rounded Rectangle 6"/>
+          <p:cNvSpPr/>
+          <p:nvPr/>
+        </p:nvSpPr>
+        <p:spPr>
+          <a:xfrm>
+            <a:off x="640080" y="1554480"/>
+            <a:ext cx="2606040" cy="1965960"/>
+          </a:xfrm>
+          <a:prstGeom prst="roundRect">
+            <a:avLst/>
+          </a:prstGeom>
+          <a:solidFill>
+            <a:srgbClr val="2E86C1"/>
+          </a:solidFill>
+          <a:ln>
+            <a:noFill/>
+          </a:ln>
+        </p:spPr>
+        <p:style>
+          <a:lnRef idx="1">
+            <a:schemeClr val="accent1"/>
+          </a:lnRef>
+          <a:fillRef idx="3">
+            <a:schemeClr val="accent1"/>
+          </a:fillRef>
+          <a:effectRef idx="2">
+            <a:schemeClr val="accent1"/>
+          </a:effectRef>
+          <a:fontRef idx="minor">
+            <a:schemeClr val="lt1"/>
+          </a:fontRef>
+        </p:style>
+        <p:txBody>
+          <a:bodyPr rtlCol="0" anchor="ctr" wrap="square" lIns="76200" rIns="76200" tIns="38100" bIns="38100"/>
+          <a:lstStyle/>
+          <a:p>
+            <a:pPr algn="ctr"/>
+            <a:r>
+              <a:rPr sz="1400" b="1">
+                <a:solidFill>
+                  <a:srgbClr val="CFDDEA"/>
+                </a:solidFill>
+                <a:latin typeface="Calibri"/>
+              </a:rPr>
+              <a:t>Today</a:t>
+            </a:r>
+          </a:p>
+          <a:p>
+            <a:pPr algn="ctr"/>
+            <a:r>
+              <a:rPr sz="3000" b="1">
+                <a:solidFill>
+                  <a:srgbClr val="FFFFFF"/>
+                </a:solidFill>
+                <a:latin typeface="Calibri"/>
+              </a:rPr>
+              <a:t>49%</a:t>
+            </a:r>
+          </a:p>
+          <a:p>
+            <a:pPr algn="ctr"/>
+            <a:r>
+              <a:rPr sz="1150" b="0">
+                <a:solidFill>
+                  <a:srgbClr val="FFFFFF"/>
+                </a:solidFill>
+                <a:latin typeface="Calibri"/>
+              </a:rPr>
+              <a:t>of GenApep · ≈ $17.2M at $35M mid</a:t>
+            </a:r>
+          </a:p>
+        </p:txBody>
+      </p:sp>
+      <p:sp>
+        <p:nvSpPr>
+          <p:cNvPr id="8" name="Right Arrow 7"/>
+          <p:cNvSpPr/>
+          <p:nvPr/>
+        </p:nvSpPr>
+        <p:spPr>
+          <a:xfrm>
+            <a:off x="3264408" y="2331720"/>
+            <a:ext cx="182880" cy="411480"/>
+          </a:xfrm>
+          <a:prstGeom prst="rightArrow">
+            <a:avLst/>
+          </a:prstGeom>
+          <a:solidFill>
+            <a:srgbClr val="5A5A5A"/>
+          </a:solidFill>
+          <a:ln>
+            <a:noFill/>
+          </a:ln>
+          <a:effectLst/>
+        </p:spPr>
+        <p:style>
+          <a:lnRef idx="1">
+            <a:schemeClr val="accent1"/>
+          </a:lnRef>
+          <a:fillRef idx="3">
+            <a:schemeClr val="accent1"/>
+          </a:fillRef>
+          <a:effectRef idx="2">
+            <a:schemeClr val="accent1"/>
+          </a:effectRef>
+          <a:fontRef idx="minor">
+            <a:schemeClr val="lt1"/>
+          </a:fontRef>
+        </p:style>
+        <p:txBody>
+          <a:bodyPr rtlCol="0" anchor="ctr"/>
+          <a:lstStyle/>
+          <a:p>
+            <a:pPr algn="ctr"/>
+          </a:p>
+        </p:txBody>
+      </p:sp>
+      <p:sp>
+        <p:nvSpPr>
+          <p:cNvPr id="9" name="Rounded Rectangle 8"/>
+          <p:cNvSpPr/>
+          <p:nvPr/>
+        </p:nvSpPr>
+        <p:spPr>
+          <a:xfrm>
+            <a:off x="3456432" y="1554480"/>
+            <a:ext cx="2606040" cy="1965960"/>
+          </a:xfrm>
+          <a:prstGeom prst="roundRect">
+            <a:avLst/>
+          </a:prstGeom>
+          <a:solidFill>
+            <a:srgbClr val="1AA19C"/>
+          </a:solidFill>
+          <a:ln>
+            <a:noFill/>
+          </a:ln>
+        </p:spPr>
+        <p:style>
+          <a:lnRef idx="1">
+            <a:schemeClr val="accent1"/>
+          </a:lnRef>
+          <a:fillRef idx="3">
+            <a:schemeClr val="accent1"/>
+          </a:fillRef>
+          <a:effectRef idx="2">
+            <a:schemeClr val="accent1"/>
+          </a:effectRef>
+          <a:fontRef idx="minor">
+            <a:schemeClr val="lt1"/>
+          </a:fontRef>
+        </p:style>
+        <p:txBody>
+          <a:bodyPr rtlCol="0" anchor="ctr" wrap="square" lIns="76200" rIns="76200" tIns="38100" bIns="38100"/>
+          <a:lstStyle/>
+          <a:p>
+            <a:pPr algn="ctr"/>
+            <a:r>
+              <a:rPr sz="1400" b="1">
+                <a:solidFill>
+                  <a:srgbClr val="CFDDEA"/>
+                </a:solidFill>
+                <a:latin typeface="Calibri"/>
+              </a:rPr>
+              <a:t>After pool (7.5%)</a:t>
+            </a:r>
+          </a:p>
+          <a:p>
+            <a:pPr algn="ctr"/>
+            <a:r>
+              <a:rPr sz="3000" b="1">
+                <a:solidFill>
+                  <a:srgbClr val="FFFFFF"/>
+                </a:solidFill>
+                <a:latin typeface="Calibri"/>
+              </a:rPr>
+              <a:t>45.3%</a:t>
+            </a:r>
+          </a:p>
+          <a:p>
+            <a:pPr algn="ctr"/>
+            <a:r>
+              <a:rPr sz="1150" b="0">
+                <a:solidFill>
+                  <a:srgbClr val="FFFFFF"/>
+                </a:solidFill>
+                <a:latin typeface="Calibri"/>
+              </a:rPr>
+              <a:t>≈ $15.9M — before technology credit</a:t>
+            </a:r>
+          </a:p>
+        </p:txBody>
+      </p:sp>
+      <p:sp>
+        <p:nvSpPr>
+          <p:cNvPr id="10" name="Right Arrow 9"/>
+          <p:cNvSpPr/>
+          <p:nvPr/>
+        </p:nvSpPr>
+        <p:spPr>
+          <a:xfrm>
+            <a:off x="6080760" y="2331720"/>
+            <a:ext cx="182880" cy="411480"/>
+          </a:xfrm>
+          <a:prstGeom prst="rightArrow">
+            <a:avLst/>
+          </a:prstGeom>
+          <a:solidFill>
+            <a:srgbClr val="5A5A5A"/>
+          </a:solidFill>
+          <a:ln>
+            <a:noFill/>
+          </a:ln>
+          <a:effectLst/>
+        </p:spPr>
+        <p:style>
+          <a:lnRef idx="1">
+            <a:schemeClr val="accent1"/>
+          </a:lnRef>
+          <a:fillRef idx="3">
+            <a:schemeClr val="accent1"/>
+          </a:fillRef>
+          <a:effectRef idx="2">
+            <a:schemeClr val="accent1"/>
+          </a:effectRef>
+          <a:fontRef idx="minor">
+            <a:schemeClr val="lt1"/>
+          </a:fontRef>
+        </p:style>
+        <p:txBody>
+          <a:bodyPr rtlCol="0" anchor="ctr"/>
+          <a:lstStyle/>
+          <a:p>
+            <a:pPr algn="ctr"/>
+          </a:p>
+        </p:txBody>
+      </p:sp>
+      <p:sp>
+        <p:nvSpPr>
+          <p:cNvPr id="11" name="Rounded Rectangle 10"/>
+          <p:cNvSpPr/>
+          <p:nvPr/>
+        </p:nvSpPr>
+        <p:spPr>
+          <a:xfrm>
+            <a:off x="6272784" y="1554480"/>
+            <a:ext cx="2606040" cy="1965960"/>
+          </a:xfrm>
+          <a:prstGeom prst="roundRect">
+            <a:avLst/>
+          </a:prstGeom>
+          <a:solidFill>
+            <a:srgbClr val="E09E2B"/>
+          </a:solidFill>
+          <a:ln>
+            <a:noFill/>
+          </a:ln>
+        </p:spPr>
+        <p:style>
+          <a:lnRef idx="1">
+            <a:schemeClr val="accent1"/>
+          </a:lnRef>
+          <a:fillRef idx="3">
+            <a:schemeClr val="accent1"/>
+          </a:fillRef>
+          <a:effectRef idx="2">
+            <a:schemeClr val="accent1"/>
+          </a:effectRef>
+          <a:fontRef idx="minor">
+            <a:schemeClr val="lt1"/>
+          </a:fontRef>
+        </p:style>
+        <p:txBody>
+          <a:bodyPr rtlCol="0" anchor="ctr" wrap="square" lIns="76200" rIns="76200" tIns="38100" bIns="38100"/>
+          <a:lstStyle/>
+          <a:p>
+            <a:pPr algn="ctr"/>
+            <a:r>
+              <a:rPr sz="1400" b="1">
+                <a:solidFill>
+                  <a:srgbClr val="FFFFFF"/>
+                </a:solidFill>
+                <a:latin typeface="Calibri"/>
+              </a:rPr>
+              <a:t>Route B (FVH $10M)</a:t>
+            </a:r>
+          </a:p>
+          <a:p>
+            <a:pPr algn="ctr"/>
+            <a:r>
+              <a:rPr sz="3000" b="1">
+                <a:solidFill>
+                  <a:srgbClr val="FFFFFF"/>
+                </a:solidFill>
+                <a:latin typeface="Calibri"/>
+              </a:rPr>
+              <a:t>35.3%</a:t>
+            </a:r>
+          </a:p>
+          <a:p>
+            <a:pPr algn="ctr"/>
+            <a:r>
+              <a:rPr sz="1150" b="0">
+                <a:solidFill>
+                  <a:srgbClr val="FFFFFF"/>
+                </a:solidFill>
+                <a:latin typeface="Calibri"/>
+              </a:rPr>
+              <a:t>of the LISTED company · $28–35M if market values group at $80–100M</a:t>
+            </a:r>
+          </a:p>
+        </p:txBody>
+      </p:sp>
+      <p:sp>
+        <p:nvSpPr>
+          <p:cNvPr id="12" name="Right Arrow 11"/>
+          <p:cNvSpPr/>
+          <p:nvPr/>
+        </p:nvSpPr>
+        <p:spPr>
+          <a:xfrm>
+            <a:off x="8897112" y="2331720"/>
+            <a:ext cx="182880" cy="411480"/>
+          </a:xfrm>
+          <a:prstGeom prst="rightArrow">
+            <a:avLst/>
+          </a:prstGeom>
+          <a:solidFill>
+            <a:srgbClr val="5A5A5A"/>
+          </a:solidFill>
+          <a:ln>
+            <a:noFill/>
+          </a:ln>
+          <a:effectLst/>
+        </p:spPr>
+        <p:style>
+          <a:lnRef idx="1">
+            <a:schemeClr val="accent1"/>
+          </a:lnRef>
+          <a:fillRef idx="3">
+            <a:schemeClr val="accent1"/>
+          </a:fillRef>
+          <a:effectRef idx="2">
+            <a:schemeClr val="accent1"/>
+          </a:effectRef>
+          <a:fontRef idx="minor">
+            <a:schemeClr val="lt1"/>
+          </a:fontRef>
+        </p:style>
+        <p:txBody>
+          <a:bodyPr rtlCol="0" anchor="ctr"/>
+          <a:lstStyle/>
+          <a:p>
+            <a:pPr algn="ctr"/>
+          </a:p>
+        </p:txBody>
+      </p:sp>
+      <p:sp>
+        <p:nvSpPr>
+          <p:cNvPr id="13" name="Rounded Rectangle 12"/>
+          <p:cNvSpPr/>
+          <p:nvPr/>
+        </p:nvSpPr>
+        <p:spPr>
+          <a:xfrm>
+            <a:off x="9089136" y="1554480"/>
+            <a:ext cx="2606040" cy="1965960"/>
+          </a:xfrm>
+          <a:prstGeom prst="roundRect">
+            <a:avLst/>
+          </a:prstGeom>
+          <a:solidFill>
+            <a:srgbClr val="1B3355"/>
+          </a:solidFill>
+          <a:ln>
+            <a:noFill/>
+          </a:ln>
+        </p:spPr>
+        <p:style>
+          <a:lnRef idx="1">
+            <a:schemeClr val="accent1"/>
+          </a:lnRef>
+          <a:fillRef idx="3">
+            <a:schemeClr val="accent1"/>
+          </a:fillRef>
+          <a:effectRef idx="2">
+            <a:schemeClr val="accent1"/>
+          </a:effectRef>
+          <a:fontRef idx="minor">
+            <a:schemeClr val="lt1"/>
+          </a:fontRef>
+        </p:style>
+        <p:txBody>
+          <a:bodyPr rtlCol="0" anchor="ctr" wrap="square" lIns="76200" rIns="76200" tIns="38100" bIns="38100"/>
+          <a:lstStyle/>
+          <a:p>
+            <a:pPr algn="ctr"/>
+            <a:r>
+              <a:rPr sz="1400" b="1">
+                <a:solidFill>
+                  <a:srgbClr val="CFDDEA"/>
+                </a:solidFill>
+                <a:latin typeface="Calibri"/>
+              </a:rPr>
+              <a:t>Route A post-IPO</a:t>
+            </a:r>
+          </a:p>
+          <a:p>
+            <a:pPr algn="ctr"/>
+            <a:r>
+              <a:rPr sz="3000" b="1">
+                <a:solidFill>
+                  <a:srgbClr val="FFFFFF"/>
+                </a:solidFill>
+                <a:latin typeface="Calibri"/>
+              </a:rPr>
+              <a:t>36.3%</a:t>
+            </a:r>
+          </a:p>
+          <a:p>
+            <a:pPr algn="ctr"/>
+            <a:r>
+              <a:rPr sz="1150" b="0">
+                <a:solidFill>
+                  <a:srgbClr val="FFFFFF"/>
+                </a:solidFill>
+                <a:latin typeface="Calibri"/>
+              </a:rPr>
+              <a:t>≈ $36.3M at $80M pre + $20M raise (workbook)</a:t>
+            </a:r>
+          </a:p>
+        </p:txBody>
+      </p:sp>
+      <p:sp>
+        <p:nvSpPr>
+          <p:cNvPr id="14" name="Rounded Rectangle 13"/>
+          <p:cNvSpPr/>
+          <p:nvPr/>
+        </p:nvSpPr>
+        <p:spPr>
+          <a:xfrm>
+            <a:off x="640080" y="3794760"/>
+            <a:ext cx="5394960" cy="2331720"/>
+          </a:xfrm>
+          <a:prstGeom prst="roundRect">
+            <a:avLst/>
+          </a:prstGeom>
+          <a:solidFill>
+            <a:srgbClr val="FFFFFF"/>
+          </a:solidFill>
+          <a:ln w="19050">
+            <a:solidFill>
+              <a:srgbClr val="2E86C1"/>
+            </a:solidFill>
+          </a:ln>
+        </p:spPr>
+        <p:style>
+          <a:lnRef idx="1">
+            <a:schemeClr val="accent1"/>
+          </a:lnRef>
+          <a:fillRef idx="3">
+            <a:schemeClr val="accent1"/>
+          </a:fillRef>
+          <a:effectRef idx="2">
+            <a:schemeClr val="accent1"/>
+          </a:effectRef>
+          <a:fontRef idx="minor">
+            <a:schemeClr val="lt1"/>
+          </a:fontRef>
+        </p:style>
+        <p:txBody>
+          <a:bodyPr rtlCol="0" anchor="t" wrap="square" lIns="127000" rIns="127000" tIns="101600"/>
+          <a:lstStyle/>
+          <a:p>
+            <a:pPr algn="l"/>
+            <a:r>
+              <a:rPr sz="1700" b="1">
+                <a:solidFill>
+                  <a:srgbClr val="1B3355"/>
+                </a:solidFill>
+                <a:latin typeface="Calibri"/>
+              </a:rPr>
+              <a:t>Where WBI's value comes from</a:t>
+            </a:r>
+          </a:p>
+          <a:p>
+            <a:pPr algn="l">
+              <a:spcBef>
+                <a:spcPts val="400"/>
+              </a:spcBef>
+            </a:pPr>
+            <a:r>
+              <a:rPr sz="1350">
+                <a:solidFill>
+                  <a:srgbClr val="5A5A5A"/>
+                </a:solidFill>
+                <a:latin typeface="Calibri"/>
+              </a:rPr>
+              <a:t>• MM Studio — WBI's growth engine: $2.9M → $36.3M by 2030, the plan's biggest swing factor.
+• WBI core exports: $4.69M in 2026, +20%/yr, NTS-certified FY2025 base.
+• Technology upside (AI.pep, DPW licence) accrues inside GenApep — you participate via the block.</a:t>
+            </a:r>
+          </a:p>
+        </p:txBody>
+      </p:sp>
+      <p:sp>
+        <p:nvSpPr>
+          <p:cNvPr id="15" name="Rounded Rectangle 14"/>
+          <p:cNvSpPr/>
+          <p:nvPr/>
+        </p:nvSpPr>
+        <p:spPr>
+          <a:xfrm>
+            <a:off x="6263640" y="3794760"/>
+            <a:ext cx="5303520" cy="2331720"/>
+          </a:xfrm>
+          <a:prstGeom prst="roundRect">
+            <a:avLst/>
+          </a:prstGeom>
+          <a:solidFill>
+            <a:srgbClr val="FFFFFF"/>
+          </a:solidFill>
+          <a:ln w="19050">
+            <a:solidFill>
+              <a:srgbClr val="C0392B"/>
+            </a:solidFill>
+          </a:ln>
+        </p:spPr>
+        <p:style>
+          <a:lnRef idx="1">
+            <a:schemeClr val="accent1"/>
+          </a:lnRef>
+          <a:fillRef idx="3">
+            <a:schemeClr val="accent1"/>
+          </a:fillRef>
+          <a:effectRef idx="2">
+            <a:schemeClr val="accent1"/>
+          </a:effectRef>
+          <a:fontRef idx="minor">
+            <a:schemeClr val="lt1"/>
+          </a:fontRef>
+        </p:style>
+        <p:txBody>
+          <a:bodyPr rtlCol="0" anchor="t" wrap="square" lIns="127000" rIns="127000" tIns="101600"/>
+          <a:lstStyle/>
+          <a:p>
+            <a:pPr algn="l"/>
+            <a:r>
+              <a:rPr sz="1700" b="1">
+                <a:solidFill>
+                  <a:srgbClr val="1B3355"/>
+                </a:solidFill>
+                <a:latin typeface="Calibri"/>
+              </a:rPr>
+              <a:t>The protections that matter to you</a:t>
+            </a:r>
+          </a:p>
+          <a:p>
+            <a:pPr algn="l">
+              <a:spcBef>
+                <a:spcPts val="400"/>
+              </a:spcBef>
+            </a:pPr>
+            <a:r>
+              <a:rPr sz="1350">
+                <a:solidFill>
+                  <a:srgbClr val="5A5A5A"/>
+                </a:solidFill>
+                <a:latin typeface="Calibri"/>
+              </a:rPr>
+              <a:t>• A2: consideration only to shareholder bodies, pro rata — the draft's 40% to one individual (zero to other WBI shareholders) becomes impossible.
+• B4/B5: any Stage-2 deal carries every shareholder through as one block at one ratio.
+• A1: if Eyesel's real revenue departs &gt;15% from $8.0M, equalisation is mandatory.</a:t>
+            </a:r>
+          </a:p>
+        </p:txBody>
+      </p:sp>
+    </p:spTree>
+  </p:cSld>
+  <p:clrMapOvr>
+    <a:masterClrMapping/>
+  </p:clrMapOvr>
+</p:sld>
+</file>
+
+<file path=ppt/slides/slide14.xml><?xml version="1.0" encoding="utf-8"?>
+<p:sld xmlns:a="http://schemas.openxmlformats.org/drawingml/2006/main" xmlns:p="http://schemas.openxmlformats.org/presentationml/2006/main" xmlns:r="http://schemas.openxmlformats.org/officeDocument/2006/relationships">
+  <p:cSld>
+    <p:spTree>
+      <p:nvGrpSpPr>
+        <p:cNvPr id="1" name=""/>
+        <p:cNvGrpSpPr/>
+        <p:nvPr/>
+      </p:nvGrpSpPr>
+      <p:grpSpPr/>
+      <p:sp>
+        <p:nvSpPr>
+          <p:cNvPr id="2" name="Rectangle 1"/>
+          <p:cNvSpPr/>
+          <p:nvPr/>
+        </p:nvSpPr>
+        <p:spPr>
+          <a:xfrm>
+            <a:off x="0" y="0"/>
+            <a:ext cx="12191695" cy="1097280"/>
+          </a:xfrm>
+          <a:prstGeom prst="rect">
+            <a:avLst/>
+          </a:prstGeom>
+          <a:solidFill>
+            <a:srgbClr val="1B3355"/>
+          </a:solidFill>
+          <a:ln>
+            <a:noFill/>
+          </a:ln>
+          <a:effectLst/>
+        </p:spPr>
+        <p:style>
+          <a:lnRef idx="1">
+            <a:schemeClr val="accent1"/>
+          </a:lnRef>
+          <a:fillRef idx="3">
+            <a:schemeClr val="accent1"/>
+          </a:fillRef>
+          <a:effectRef idx="2">
+            <a:schemeClr val="accent1"/>
+          </a:effectRef>
+          <a:fontRef idx="minor">
+            <a:schemeClr val="lt1"/>
+          </a:fontRef>
+        </p:style>
+        <p:txBody>
+          <a:bodyPr rtlCol="0" anchor="ctr"/>
+          <a:lstStyle/>
+          <a:p>
+            <a:pPr algn="ctr"/>
+          </a:p>
+        </p:txBody>
+      </p:sp>
+      <p:sp>
+        <p:nvSpPr>
+          <p:cNvPr id="3" name="Rectangle 2"/>
+          <p:cNvSpPr/>
+          <p:nvPr/>
+        </p:nvSpPr>
+        <p:spPr>
+          <a:xfrm>
+            <a:off x="502920" y="310896"/>
+            <a:ext cx="128016" cy="475488"/>
+          </a:xfrm>
+          <a:prstGeom prst="rect">
+            <a:avLst/>
+          </a:prstGeom>
+          <a:solidFill>
+            <a:srgbClr val="2E86C1"/>
+          </a:solidFill>
+          <a:ln>
+            <a:noFill/>
+          </a:ln>
+          <a:effectLst/>
+        </p:spPr>
+        <p:style>
+          <a:lnRef idx="1">
+            <a:schemeClr val="accent1"/>
+          </a:lnRef>
+          <a:fillRef idx="3">
+            <a:schemeClr val="accent1"/>
+          </a:fillRef>
+          <a:effectRef idx="2">
+            <a:schemeClr val="accent1"/>
+          </a:effectRef>
+          <a:fontRef idx="minor">
+            <a:schemeClr val="lt1"/>
+          </a:fontRef>
+        </p:style>
+        <p:txBody>
+          <a:bodyPr rtlCol="0" anchor="ctr"/>
+          <a:lstStyle/>
+          <a:p>
+            <a:pPr algn="ctr"/>
+          </a:p>
+        </p:txBody>
+      </p:sp>
+      <p:sp>
+        <p:nvSpPr>
+          <p:cNvPr id="4" name="TextBox 3"/>
+          <p:cNvSpPr txBox="1"/>
+          <p:nvPr/>
+        </p:nvSpPr>
+        <p:spPr>
+          <a:xfrm>
+            <a:off x="777240" y="164592"/>
+            <a:ext cx="10607040" cy="822960"/>
+          </a:xfrm>
+          <a:prstGeom prst="rect">
+            <a:avLst/>
+          </a:prstGeom>
+          <a:noFill/>
+        </p:spPr>
+        <p:txBody>
+          <a:bodyPr wrap="square" anchor="ctr">
+            <a:spAutoFit/>
+          </a:bodyPr>
+          <a:lstStyle/>
+          <a:p>
+            <a:pPr algn="l">
+              <a:spcAft>
+                <a:spcPts val="400"/>
+              </a:spcAft>
+            </a:pPr>
+            <a:r>
+              <a:rPr sz="2700" b="1">
+                <a:solidFill>
+                  <a:srgbClr val="FFFFFF"/>
+                </a:solidFill>
+                <a:latin typeface="Calibri"/>
+              </a:rPr>
+              <a:t>The price test on First Vital</a:t>
+            </a:r>
+          </a:p>
+        </p:txBody>
+      </p:sp>
+      <p:sp>
+        <p:nvSpPr>
+          <p:cNvPr id="5" name="TextBox 4"/>
+          <p:cNvSpPr txBox="1"/>
+          <p:nvPr/>
+        </p:nvSpPr>
+        <p:spPr>
+          <a:xfrm>
+            <a:off x="795528" y="786384"/>
+            <a:ext cx="10607040" cy="274320"/>
+          </a:xfrm>
+          <a:prstGeom prst="rect">
+            <a:avLst/>
+          </a:prstGeom>
+          <a:noFill/>
+        </p:spPr>
+        <p:txBody>
+          <a:bodyPr wrap="square" anchor="t">
+            <a:spAutoFit/>
+          </a:bodyPr>
+          <a:lstStyle/>
+          <a:p>
+            <a:pPr algn="l">
+              <a:spcAft>
+                <a:spcPts val="400"/>
+              </a:spcAft>
+            </a:pPr>
+            <a:r>
+              <a:rPr sz="1400" b="0">
+                <a:solidFill>
+                  <a:srgbClr val="CFDDEA"/>
+                </a:solidFill>
+                <a:latin typeface="Calibri"/>
+              </a:rPr>
+              <a:t>What the draft's percentages imply — and how to check them</a:t>
+            </a:r>
+          </a:p>
+        </p:txBody>
+      </p:sp>
+      <p:sp>
+        <p:nvSpPr>
+          <p:cNvPr id="6" name="TextBox 5"/>
+          <p:cNvSpPr txBox="1"/>
+          <p:nvPr/>
+        </p:nvSpPr>
+        <p:spPr>
+          <a:xfrm>
+            <a:off x="11338560" y="6437376"/>
+            <a:ext cx="731520" cy="320040"/>
+          </a:xfrm>
+          <a:prstGeom prst="rect">
+            <a:avLst/>
+          </a:prstGeom>
+          <a:noFill/>
+        </p:spPr>
+        <p:txBody>
+          <a:bodyPr wrap="square" anchor="t">
+            <a:spAutoFit/>
+          </a:bodyPr>
+          <a:lstStyle/>
+          <a:p>
+            <a:pPr algn="r">
+              <a:spcAft>
+                <a:spcPts val="400"/>
+              </a:spcAft>
+            </a:pPr>
+            <a:r>
+              <a:rPr sz="1200" b="0">
+                <a:solidFill>
+                  <a:srgbClr val="5A5A5A"/>
+                </a:solidFill>
+                <a:latin typeface="Calibri"/>
+              </a:rPr>
+              <a:t>14</a:t>
             </a:r>
           </a:p>
         </p:txBody>
@@ -7290,382 +8116,6 @@
 </p:sld>
 </file>
 
-<file path=ppt/slides/slide14.xml><?xml version="1.0" encoding="utf-8"?>
-<p:sld xmlns:a="http://schemas.openxmlformats.org/drawingml/2006/main" xmlns:p="http://schemas.openxmlformats.org/presentationml/2006/main" xmlns:r="http://schemas.openxmlformats.org/officeDocument/2006/relationships">
-  <p:cSld>
-    <p:spTree>
-      <p:nvGrpSpPr>
-        <p:cNvPr id="1" name=""/>
-        <p:cNvGrpSpPr/>
-        <p:nvPr/>
-      </p:nvGrpSpPr>
-      <p:grpSpPr/>
-      <p:sp>
-        <p:nvSpPr>
-          <p:cNvPr id="2" name="Rectangle 1"/>
-          <p:cNvSpPr/>
-          <p:nvPr/>
-        </p:nvSpPr>
-        <p:spPr>
-          <a:xfrm>
-            <a:off x="0" y="0"/>
-            <a:ext cx="12191695" cy="1097280"/>
-          </a:xfrm>
-          <a:prstGeom prst="rect">
-            <a:avLst/>
-          </a:prstGeom>
-          <a:solidFill>
-            <a:srgbClr val="1B3355"/>
-          </a:solidFill>
-          <a:ln>
-            <a:noFill/>
-          </a:ln>
-          <a:effectLst/>
-        </p:spPr>
-        <p:style>
-          <a:lnRef idx="1">
-            <a:schemeClr val="accent1"/>
-          </a:lnRef>
-          <a:fillRef idx="3">
-            <a:schemeClr val="accent1"/>
-          </a:fillRef>
-          <a:effectRef idx="2">
-            <a:schemeClr val="accent1"/>
-          </a:effectRef>
-          <a:fontRef idx="minor">
-            <a:schemeClr val="lt1"/>
-          </a:fontRef>
-        </p:style>
-        <p:txBody>
-          <a:bodyPr rtlCol="0" anchor="ctr"/>
-          <a:lstStyle/>
-          <a:p>
-            <a:pPr algn="ctr"/>
-          </a:p>
-        </p:txBody>
-      </p:sp>
-      <p:sp>
-        <p:nvSpPr>
-          <p:cNvPr id="3" name="Rectangle 2"/>
-          <p:cNvSpPr/>
-          <p:nvPr/>
-        </p:nvSpPr>
-        <p:spPr>
-          <a:xfrm>
-            <a:off x="502920" y="310896"/>
-            <a:ext cx="128016" cy="475488"/>
-          </a:xfrm>
-          <a:prstGeom prst="rect">
-            <a:avLst/>
-          </a:prstGeom>
-          <a:solidFill>
-            <a:srgbClr val="2E86C1"/>
-          </a:solidFill>
-          <a:ln>
-            <a:noFill/>
-          </a:ln>
-          <a:effectLst/>
-        </p:spPr>
-        <p:style>
-          <a:lnRef idx="1">
-            <a:schemeClr val="accent1"/>
-          </a:lnRef>
-          <a:fillRef idx="3">
-            <a:schemeClr val="accent1"/>
-          </a:fillRef>
-          <a:effectRef idx="2">
-            <a:schemeClr val="accent1"/>
-          </a:effectRef>
-          <a:fontRef idx="minor">
-            <a:schemeClr val="lt1"/>
-          </a:fontRef>
-        </p:style>
-        <p:txBody>
-          <a:bodyPr rtlCol="0" anchor="ctr"/>
-          <a:lstStyle/>
-          <a:p>
-            <a:pPr algn="ctr"/>
-          </a:p>
-        </p:txBody>
-      </p:sp>
-      <p:sp>
-        <p:nvSpPr>
-          <p:cNvPr id="4" name="TextBox 3"/>
-          <p:cNvSpPr txBox="1"/>
-          <p:nvPr/>
-        </p:nvSpPr>
-        <p:spPr>
-          <a:xfrm>
-            <a:off x="777240" y="164592"/>
-            <a:ext cx="10607040" cy="822960"/>
-          </a:xfrm>
-          <a:prstGeom prst="rect">
-            <a:avLst/>
-          </a:prstGeom>
-          <a:noFill/>
-        </p:spPr>
-        <p:txBody>
-          <a:bodyPr wrap="square" anchor="ctr">
-            <a:spAutoFit/>
-          </a:bodyPr>
-          <a:lstStyle/>
-          <a:p>
-            <a:pPr algn="l">
-              <a:spcAft>
-                <a:spcPts val="400"/>
-              </a:spcAft>
-            </a:pPr>
-            <a:r>
-              <a:rPr sz="2700" b="1">
-                <a:solidFill>
-                  <a:srgbClr val="FFFFFF"/>
-                </a:solidFill>
-                <a:latin typeface="Calibri"/>
-              </a:rPr>
-              <a:t>Protections already drafted</a:t>
-            </a:r>
-          </a:p>
-        </p:txBody>
-      </p:sp>
-      <p:sp>
-        <p:nvSpPr>
-          <p:cNvPr id="5" name="TextBox 4"/>
-          <p:cNvSpPr txBox="1"/>
-          <p:nvPr/>
-        </p:nvSpPr>
-        <p:spPr>
-          <a:xfrm>
-            <a:off x="795528" y="786384"/>
-            <a:ext cx="10607040" cy="274320"/>
-          </a:xfrm>
-          <a:prstGeom prst="rect">
-            <a:avLst/>
-          </a:prstGeom>
-          <a:noFill/>
-        </p:spPr>
-        <p:txBody>
-          <a:bodyPr wrap="square" anchor="t">
-            <a:spAutoFit/>
-          </a:bodyPr>
-          <a:lstStyle/>
-          <a:p>
-            <a:pPr algn="l">
-              <a:spcAft>
-                <a:spcPts val="400"/>
-              </a:spcAft>
-            </a:pPr>
-            <a:r>
-              <a:rPr sz="1400" b="0">
-                <a:solidFill>
-                  <a:srgbClr val="CFDDEA"/>
-                </a:solidFill>
-                <a:latin typeface="Calibri"/>
-              </a:rPr>
-              <a:t>Sign Amendment No. 1 now; Addendum A when Route B is live</a:t>
-            </a:r>
-          </a:p>
-        </p:txBody>
-      </p:sp>
-      <p:sp>
-        <p:nvSpPr>
-          <p:cNvPr id="6" name="TextBox 5"/>
-          <p:cNvSpPr txBox="1"/>
-          <p:nvPr/>
-        </p:nvSpPr>
-        <p:spPr>
-          <a:xfrm>
-            <a:off x="11338560" y="6437376"/>
-            <a:ext cx="731520" cy="320040"/>
-          </a:xfrm>
-          <a:prstGeom prst="rect">
-            <a:avLst/>
-          </a:prstGeom>
-          <a:noFill/>
-        </p:spPr>
-        <p:txBody>
-          <a:bodyPr wrap="square" anchor="t">
-            <a:spAutoFit/>
-          </a:bodyPr>
-          <a:lstStyle/>
-          <a:p>
-            <a:pPr algn="r">
-              <a:spcAft>
-                <a:spcPts val="400"/>
-              </a:spcAft>
-            </a:pPr>
-            <a:r>
-              <a:rPr sz="1200" b="0">
-                <a:solidFill>
-                  <a:srgbClr val="5A5A5A"/>
-                </a:solidFill>
-                <a:latin typeface="Calibri"/>
-              </a:rPr>
-              <a:t>14</a:t>
-            </a:r>
-          </a:p>
-        </p:txBody>
-      </p:sp>
-      <p:sp>
-        <p:nvSpPr>
-          <p:cNvPr id="7" name="Rounded Rectangle 6"/>
-          <p:cNvSpPr/>
-          <p:nvPr/>
-        </p:nvSpPr>
-        <p:spPr>
-          <a:xfrm>
-            <a:off x="640080" y="1463040"/>
-            <a:ext cx="5394960" cy="4663440"/>
-          </a:xfrm>
-          <a:prstGeom prst="roundRect">
-            <a:avLst/>
-          </a:prstGeom>
-          <a:solidFill>
-            <a:srgbClr val="FFFFFF"/>
-          </a:solidFill>
-          <a:ln w="19050">
-            <a:solidFill>
-              <a:srgbClr val="2E86C1"/>
-            </a:solidFill>
-          </a:ln>
-        </p:spPr>
-        <p:style>
-          <a:lnRef idx="1">
-            <a:schemeClr val="accent1"/>
-          </a:lnRef>
-          <a:fillRef idx="3">
-            <a:schemeClr val="accent1"/>
-          </a:fillRef>
-          <a:effectRef idx="2">
-            <a:schemeClr val="accent1"/>
-          </a:effectRef>
-          <a:fontRef idx="minor">
-            <a:schemeClr val="lt1"/>
-          </a:fontRef>
-        </p:style>
-        <p:txBody>
-          <a:bodyPr rtlCol="0" anchor="t" wrap="square" lIns="127000" rIns="127000" tIns="101600"/>
-          <a:lstStyle/>
-          <a:p>
-            <a:pPr algn="l"/>
-            <a:r>
-              <a:rPr sz="1700" b="1">
-                <a:solidFill>
-                  <a:srgbClr val="1B3355"/>
-                </a:solidFill>
-                <a:latin typeface="Calibri"/>
-              </a:rPr>
-              <a:t>Amendment No. 1 (both scenarios)</a:t>
-            </a:r>
-          </a:p>
-          <a:p>
-            <a:pPr algn="l">
-              <a:spcBef>
-                <a:spcPts val="400"/>
-              </a:spcBef>
-            </a:pPr>
-            <a:r>
-              <a:rPr sz="1350">
-                <a:solidFill>
-                  <a:srgbClr val="5A5A5A"/>
-                </a:solidFill>
-                <a:latin typeface="Calibri"/>
-              </a:rPr>
-              <a:t>A1 · Equalisation becomes MANDATORY beyond 15% variance — independent valuer decides if boards cannot.
-A2 · Consideration to shareholder bodies pro rata, never to principals.
-A3/A4 · Third-Director interests disclosed; deadlocks resolved (pool fixed at 7.5% fallback).
-A5 · Technology chain of title = condition precedent to completion.
-A6/A7 · Technology encumbrances disclosed; provenance pack before sweat-equity vesting.
-A8 · No one may present GenApep as an existing rights-holding entity before it is one.
-A9 · Open items scheduled with owners and dates.</a:t>
-            </a:r>
-          </a:p>
-        </p:txBody>
-      </p:sp>
-      <p:sp>
-        <p:nvSpPr>
-          <p:cNvPr id="8" name="Rounded Rectangle 7"/>
-          <p:cNvSpPr/>
-          <p:nvPr/>
-        </p:nvSpPr>
-        <p:spPr>
-          <a:xfrm>
-            <a:off x="6263640" y="1463040"/>
-            <a:ext cx="5303520" cy="4663440"/>
-          </a:xfrm>
-          <a:prstGeom prst="roundRect">
-            <a:avLst/>
-          </a:prstGeom>
-          <a:solidFill>
-            <a:srgbClr val="FFFFFF"/>
-          </a:solidFill>
-          <a:ln w="19050">
-            <a:solidFill>
-              <a:srgbClr val="E09E2B"/>
-            </a:solidFill>
-          </a:ln>
-        </p:spPr>
-        <p:style>
-          <a:lnRef idx="1">
-            <a:schemeClr val="accent1"/>
-          </a:lnRef>
-          <a:fillRef idx="3">
-            <a:schemeClr val="accent1"/>
-          </a:fillRef>
-          <a:effectRef idx="2">
-            <a:schemeClr val="accent1"/>
-          </a:effectRef>
-          <a:fontRef idx="minor">
-            <a:schemeClr val="lt1"/>
-          </a:fontRef>
-        </p:style>
-        <p:txBody>
-          <a:bodyPr rtlCol="0" anchor="t" wrap="square" lIns="127000" rIns="127000" tIns="101600"/>
-          <a:lstStyle/>
-          <a:p>
-            <a:pPr algn="l"/>
-            <a:r>
-              <a:rPr sz="1700" b="1">
-                <a:solidFill>
-                  <a:srgbClr val="1B3355"/>
-                </a:solidFill>
-                <a:latin typeface="Calibri"/>
-              </a:rPr>
-              <a:t>Addendum A (Route-B machinery)</a:t>
-            </a:r>
-          </a:p>
-          <a:p>
-            <a:pPr algn="l">
-              <a:spcBef>
-                <a:spcPts val="400"/>
-              </a:spcBef>
-            </a:pPr>
-            <a:r>
-              <a:rPr sz="1350">
-                <a:solidFill>
-                  <a:srgbClr val="5A5A5A"/>
-                </a:solidFill>
-                <a:latin typeface="Calibri"/>
-              </a:rPr>
-              <a:t>B1 · GenApep Korea is the ONLY permitted acquisition vehicle.
-B2 · Sweat pool carries into any new structure on equivalent terms.
-B3 · Route selection is a Reserved Matter; Route A stays the default.
-B4 · Ratio preservation: consideration strictly pro rata — binding.
-B5 · Block entry: one exchange ratio for the whole JV, never individual deals.
-B6/B11 · No unilateral negotiation; exclusivity extends to listing vehicles.
-B7 · Related-party deals need valuations, fairness opinion, disinterested approval.
-B8–B10, B12 · Verification gates, audit scoped for either route, consequences schedule.</a:t>
-            </a:r>
-          </a:p>
-        </p:txBody>
-      </p:sp>
-    </p:spTree>
-  </p:cSld>
-  <p:clrMapOvr>
-    <a:masterClrMapping/>
-  </p:clrMapOvr>
-</p:sld>
-</file>
-
 <file path=ppt/slides/slide15.xml><?xml version="1.0" encoding="utf-8"?>
 <p:sld xmlns:a="http://schemas.openxmlformats.org/drawingml/2006/main" xmlns:p="http://schemas.openxmlformats.org/presentationml/2006/main" xmlns:r="http://schemas.openxmlformats.org/officeDocument/2006/relationships">
   <p:cSld>
@@ -7798,7 +8248,7 @@
                 </a:solidFill>
                 <a:latin typeface="Calibri"/>
               </a:rPr>
-              <a:t>Timeline &amp; critical path</a:t>
+              <a:t>Protections already drafted</a:t>
             </a:r>
           </a:p>
         </p:txBody>
@@ -7837,7 +8287,7 @@
                 </a:solidFill>
                 <a:latin typeface="Calibri"/>
               </a:rPr>
-              <a:t>The audit is the clock; everything else runs in parallel</a:t>
+              <a:t>Sign Amendment No. 1 now; Addendum A when Route B is live</a:t>
             </a:r>
           </a:p>
         </p:txBody>
@@ -7877,6 +8327,382 @@
                 <a:latin typeface="Calibri"/>
               </a:rPr>
               <a:t>15</a:t>
+            </a:r>
+          </a:p>
+        </p:txBody>
+      </p:sp>
+      <p:sp>
+        <p:nvSpPr>
+          <p:cNvPr id="7" name="Rounded Rectangle 6"/>
+          <p:cNvSpPr/>
+          <p:nvPr/>
+        </p:nvSpPr>
+        <p:spPr>
+          <a:xfrm>
+            <a:off x="640080" y="1463040"/>
+            <a:ext cx="5394960" cy="4663440"/>
+          </a:xfrm>
+          <a:prstGeom prst="roundRect">
+            <a:avLst/>
+          </a:prstGeom>
+          <a:solidFill>
+            <a:srgbClr val="FFFFFF"/>
+          </a:solidFill>
+          <a:ln w="19050">
+            <a:solidFill>
+              <a:srgbClr val="2E86C1"/>
+            </a:solidFill>
+          </a:ln>
+        </p:spPr>
+        <p:style>
+          <a:lnRef idx="1">
+            <a:schemeClr val="accent1"/>
+          </a:lnRef>
+          <a:fillRef idx="3">
+            <a:schemeClr val="accent1"/>
+          </a:fillRef>
+          <a:effectRef idx="2">
+            <a:schemeClr val="accent1"/>
+          </a:effectRef>
+          <a:fontRef idx="minor">
+            <a:schemeClr val="lt1"/>
+          </a:fontRef>
+        </p:style>
+        <p:txBody>
+          <a:bodyPr rtlCol="0" anchor="t" wrap="square" lIns="127000" rIns="127000" tIns="101600"/>
+          <a:lstStyle/>
+          <a:p>
+            <a:pPr algn="l"/>
+            <a:r>
+              <a:rPr sz="1700" b="1">
+                <a:solidFill>
+                  <a:srgbClr val="1B3355"/>
+                </a:solidFill>
+                <a:latin typeface="Calibri"/>
+              </a:rPr>
+              <a:t>Amendment No. 1 (both scenarios)</a:t>
+            </a:r>
+          </a:p>
+          <a:p>
+            <a:pPr algn="l">
+              <a:spcBef>
+                <a:spcPts val="400"/>
+              </a:spcBef>
+            </a:pPr>
+            <a:r>
+              <a:rPr sz="1350">
+                <a:solidFill>
+                  <a:srgbClr val="5A5A5A"/>
+                </a:solidFill>
+                <a:latin typeface="Calibri"/>
+              </a:rPr>
+              <a:t>A1 · Equalisation becomes MANDATORY beyond 15% variance — independent valuer decides if boards cannot.
+A2 · Consideration to shareholder bodies pro rata, never to principals.
+A3/A4 · Third-Director interests disclosed; deadlocks resolved (pool fixed at 7.5% fallback).
+A5 · Technology chain of title = condition precedent to completion.
+A6/A7 · Technology encumbrances disclosed; provenance pack before sweat-equity vesting.
+A8 · No one may present GenApep as an existing rights-holding entity before it is one.
+A9 · Open items scheduled with owners and dates.</a:t>
+            </a:r>
+          </a:p>
+        </p:txBody>
+      </p:sp>
+      <p:sp>
+        <p:nvSpPr>
+          <p:cNvPr id="8" name="Rounded Rectangle 7"/>
+          <p:cNvSpPr/>
+          <p:nvPr/>
+        </p:nvSpPr>
+        <p:spPr>
+          <a:xfrm>
+            <a:off x="6263640" y="1463040"/>
+            <a:ext cx="5303520" cy="4663440"/>
+          </a:xfrm>
+          <a:prstGeom prst="roundRect">
+            <a:avLst/>
+          </a:prstGeom>
+          <a:solidFill>
+            <a:srgbClr val="FFFFFF"/>
+          </a:solidFill>
+          <a:ln w="19050">
+            <a:solidFill>
+              <a:srgbClr val="E09E2B"/>
+            </a:solidFill>
+          </a:ln>
+        </p:spPr>
+        <p:style>
+          <a:lnRef idx="1">
+            <a:schemeClr val="accent1"/>
+          </a:lnRef>
+          <a:fillRef idx="3">
+            <a:schemeClr val="accent1"/>
+          </a:fillRef>
+          <a:effectRef idx="2">
+            <a:schemeClr val="accent1"/>
+          </a:effectRef>
+          <a:fontRef idx="minor">
+            <a:schemeClr val="lt1"/>
+          </a:fontRef>
+        </p:style>
+        <p:txBody>
+          <a:bodyPr rtlCol="0" anchor="t" wrap="square" lIns="127000" rIns="127000" tIns="101600"/>
+          <a:lstStyle/>
+          <a:p>
+            <a:pPr algn="l"/>
+            <a:r>
+              <a:rPr sz="1700" b="1">
+                <a:solidFill>
+                  <a:srgbClr val="1B3355"/>
+                </a:solidFill>
+                <a:latin typeface="Calibri"/>
+              </a:rPr>
+              <a:t>Addendum A (Route-B machinery)</a:t>
+            </a:r>
+          </a:p>
+          <a:p>
+            <a:pPr algn="l">
+              <a:spcBef>
+                <a:spcPts val="400"/>
+              </a:spcBef>
+            </a:pPr>
+            <a:r>
+              <a:rPr sz="1350">
+                <a:solidFill>
+                  <a:srgbClr val="5A5A5A"/>
+                </a:solidFill>
+                <a:latin typeface="Calibri"/>
+              </a:rPr>
+              <a:t>B1 · GenApep Korea is the ONLY permitted acquisition vehicle.
+B2 · Sweat pool carries into any new structure on equivalent terms.
+B3 · Route selection is a Reserved Matter; Route A stays the default.
+B4 · Ratio preservation: consideration strictly pro rata — binding.
+B5 · Block entry: one exchange ratio for the whole JV, never individual deals.
+B6/B11 · No unilateral negotiation; exclusivity extends to listing vehicles.
+B7 · Related-party deals need valuations, fairness opinion, disinterested approval.
+B8–B10, B12 · Verification gates, audit scoped for either route, consequences schedule.</a:t>
+            </a:r>
+          </a:p>
+        </p:txBody>
+      </p:sp>
+    </p:spTree>
+  </p:cSld>
+  <p:clrMapOvr>
+    <a:masterClrMapping/>
+  </p:clrMapOvr>
+</p:sld>
+</file>
+
+<file path=ppt/slides/slide16.xml><?xml version="1.0" encoding="utf-8"?>
+<p:sld xmlns:a="http://schemas.openxmlformats.org/drawingml/2006/main" xmlns:p="http://schemas.openxmlformats.org/presentationml/2006/main" xmlns:r="http://schemas.openxmlformats.org/officeDocument/2006/relationships">
+  <p:cSld>
+    <p:spTree>
+      <p:nvGrpSpPr>
+        <p:cNvPr id="1" name=""/>
+        <p:cNvGrpSpPr/>
+        <p:nvPr/>
+      </p:nvGrpSpPr>
+      <p:grpSpPr/>
+      <p:sp>
+        <p:nvSpPr>
+          <p:cNvPr id="2" name="Rectangle 1"/>
+          <p:cNvSpPr/>
+          <p:nvPr/>
+        </p:nvSpPr>
+        <p:spPr>
+          <a:xfrm>
+            <a:off x="0" y="0"/>
+            <a:ext cx="12191695" cy="1097280"/>
+          </a:xfrm>
+          <a:prstGeom prst="rect">
+            <a:avLst/>
+          </a:prstGeom>
+          <a:solidFill>
+            <a:srgbClr val="1B3355"/>
+          </a:solidFill>
+          <a:ln>
+            <a:noFill/>
+          </a:ln>
+          <a:effectLst/>
+        </p:spPr>
+        <p:style>
+          <a:lnRef idx="1">
+            <a:schemeClr val="accent1"/>
+          </a:lnRef>
+          <a:fillRef idx="3">
+            <a:schemeClr val="accent1"/>
+          </a:fillRef>
+          <a:effectRef idx="2">
+            <a:schemeClr val="accent1"/>
+          </a:effectRef>
+          <a:fontRef idx="minor">
+            <a:schemeClr val="lt1"/>
+          </a:fontRef>
+        </p:style>
+        <p:txBody>
+          <a:bodyPr rtlCol="0" anchor="ctr"/>
+          <a:lstStyle/>
+          <a:p>
+            <a:pPr algn="ctr"/>
+          </a:p>
+        </p:txBody>
+      </p:sp>
+      <p:sp>
+        <p:nvSpPr>
+          <p:cNvPr id="3" name="Rectangle 2"/>
+          <p:cNvSpPr/>
+          <p:nvPr/>
+        </p:nvSpPr>
+        <p:spPr>
+          <a:xfrm>
+            <a:off x="502920" y="310896"/>
+            <a:ext cx="128016" cy="475488"/>
+          </a:xfrm>
+          <a:prstGeom prst="rect">
+            <a:avLst/>
+          </a:prstGeom>
+          <a:solidFill>
+            <a:srgbClr val="2E86C1"/>
+          </a:solidFill>
+          <a:ln>
+            <a:noFill/>
+          </a:ln>
+          <a:effectLst/>
+        </p:spPr>
+        <p:style>
+          <a:lnRef idx="1">
+            <a:schemeClr val="accent1"/>
+          </a:lnRef>
+          <a:fillRef idx="3">
+            <a:schemeClr val="accent1"/>
+          </a:fillRef>
+          <a:effectRef idx="2">
+            <a:schemeClr val="accent1"/>
+          </a:effectRef>
+          <a:fontRef idx="minor">
+            <a:schemeClr val="lt1"/>
+          </a:fontRef>
+        </p:style>
+        <p:txBody>
+          <a:bodyPr rtlCol="0" anchor="ctr"/>
+          <a:lstStyle/>
+          <a:p>
+            <a:pPr algn="ctr"/>
+          </a:p>
+        </p:txBody>
+      </p:sp>
+      <p:sp>
+        <p:nvSpPr>
+          <p:cNvPr id="4" name="TextBox 3"/>
+          <p:cNvSpPr txBox="1"/>
+          <p:nvPr/>
+        </p:nvSpPr>
+        <p:spPr>
+          <a:xfrm>
+            <a:off x="777240" y="164592"/>
+            <a:ext cx="10607040" cy="822960"/>
+          </a:xfrm>
+          <a:prstGeom prst="rect">
+            <a:avLst/>
+          </a:prstGeom>
+          <a:noFill/>
+        </p:spPr>
+        <p:txBody>
+          <a:bodyPr wrap="square" anchor="ctr">
+            <a:spAutoFit/>
+          </a:bodyPr>
+          <a:lstStyle/>
+          <a:p>
+            <a:pPr algn="l">
+              <a:spcAft>
+                <a:spcPts val="400"/>
+              </a:spcAft>
+            </a:pPr>
+            <a:r>
+              <a:rPr sz="2700" b="1">
+                <a:solidFill>
+                  <a:srgbClr val="FFFFFF"/>
+                </a:solidFill>
+                <a:latin typeface="Calibri"/>
+              </a:rPr>
+              <a:t>Timeline &amp; critical path</a:t>
+            </a:r>
+          </a:p>
+        </p:txBody>
+      </p:sp>
+      <p:sp>
+        <p:nvSpPr>
+          <p:cNvPr id="5" name="TextBox 4"/>
+          <p:cNvSpPr txBox="1"/>
+          <p:nvPr/>
+        </p:nvSpPr>
+        <p:spPr>
+          <a:xfrm>
+            <a:off x="795528" y="786384"/>
+            <a:ext cx="10607040" cy="274320"/>
+          </a:xfrm>
+          <a:prstGeom prst="rect">
+            <a:avLst/>
+          </a:prstGeom>
+          <a:noFill/>
+        </p:spPr>
+        <p:txBody>
+          <a:bodyPr wrap="square" anchor="t">
+            <a:spAutoFit/>
+          </a:bodyPr>
+          <a:lstStyle/>
+          <a:p>
+            <a:pPr algn="l">
+              <a:spcAft>
+                <a:spcPts val="400"/>
+              </a:spcAft>
+            </a:pPr>
+            <a:r>
+              <a:rPr sz="1400" b="0">
+                <a:solidFill>
+                  <a:srgbClr val="CFDDEA"/>
+                </a:solidFill>
+                <a:latin typeface="Calibri"/>
+              </a:rPr>
+              <a:t>The audit is the clock; everything else runs in parallel</a:t>
+            </a:r>
+          </a:p>
+        </p:txBody>
+      </p:sp>
+      <p:sp>
+        <p:nvSpPr>
+          <p:cNvPr id="6" name="TextBox 5"/>
+          <p:cNvSpPr txBox="1"/>
+          <p:nvPr/>
+        </p:nvSpPr>
+        <p:spPr>
+          <a:xfrm>
+            <a:off x="11338560" y="6437376"/>
+            <a:ext cx="731520" cy="320040"/>
+          </a:xfrm>
+          <a:prstGeom prst="rect">
+            <a:avLst/>
+          </a:prstGeom>
+          <a:noFill/>
+        </p:spPr>
+        <p:txBody>
+          <a:bodyPr wrap="square" anchor="t">
+            <a:spAutoFit/>
+          </a:bodyPr>
+          <a:lstStyle/>
+          <a:p>
+            <a:pPr algn="r">
+              <a:spcAft>
+                <a:spcPts val="400"/>
+              </a:spcAft>
+            </a:pPr>
+            <a:r>
+              <a:rPr sz="1200" b="0">
+                <a:solidFill>
+                  <a:srgbClr val="5A5A5A"/>
+                </a:solidFill>
+                <a:latin typeface="Calibri"/>
+              </a:rPr>
+              <a:t>16</a:t>
             </a:r>
           </a:p>
         </p:txBody>
@@ -8581,7 +9407,7 @@
 </p:sld>
 </file>
 
-<file path=ppt/slides/slide16.xml><?xml version="1.0" encoding="utf-8"?>
+<file path=ppt/slides/slide17.xml><?xml version="1.0" encoding="utf-8"?>
 <p:sld xmlns:a="http://schemas.openxmlformats.org/drawingml/2006/main" xmlns:p="http://schemas.openxmlformats.org/presentationml/2006/main" xmlns:r="http://schemas.openxmlformats.org/officeDocument/2006/relationships">
   <p:cSld>
     <p:spTree>
@@ -8791,7 +9617,7 @@
                 </a:solidFill>
                 <a:latin typeface="Calibri"/>
               </a:rPr>
-              <a:t>16</a:t>
+              <a:t>17</a:t>
             </a:r>
           </a:p>
         </p:txBody>

</xml_diff>